<commit_message>
Fix roles table not rendering on slide 5
Co-Authored-By: Claude Opus 5.5 <noreply@anthropic.com>
Claude-Session: https://claude.ai/code/session_01GMKyVDUQoZg6CdmYZMtmh4
</commit_message>
<xml_diff>
--- a/proposal.pptx
+++ b/proposal.pptx
@@ -5427,886 +5427,832 @@
           </a:ln>
         </p:spPr>
       </p:sp>
-      <p:graphicFrame>
-        <p:nvGraphicFramePr>
-          <p:cNvPr id="6" name="Table 0"/>
-          <p:cNvGraphicFramePr>
-            <a:graphicFrameLocks noGrp="1"/>
-          </p:cNvGraphicFramePr>
-          <p:nvPr>
-            <p:extLst>
-              <p:ext uri="{D42A27DB-BD31-4B8C-83A1-F6EECF244321}">
-                <p14:modId xmlns:p14="http://schemas.microsoft.com/office/powerpoint/2010/main" val="1579011935"/>
-              </p:ext>
-            </p:extLst>
-          </p:nvPr>
-        </p:nvGraphicFramePr>
-        <p:xfrm>
-          <a:off x="4023360" y="1481328"/>
-          <a:ext cx="4389120" cy="914400"/>
-        </p:xfrm>
-        <a:graphic>
-          <a:graphicData uri="http://schemas.openxmlformats.org/drawingml/2006/table">
-            <a:tbl>
-              <a:tblPr/>
-              <a:tblGrid>
-                <a:gridCol w="1005840"/>
-                <a:gridCol w="1783080"/>
-                <a:gridCol w="1600200"/>
-              </a:tblGrid>
-              <a:tr h="438912">
-                <a:tc>
-                  <a:txBody>
-                    <a:bodyPr/>
-                    <a:lstStyle/>
-                    <a:p>
-                      <a:pPr indent="0" marL="0">
-                        <a:buNone/>
-                      </a:pPr>
-                      <a:r>
-                        <a:rPr lang="en-US" sz="950" dirty="0">
-                          <a:solidFill>
-                            <a:srgbClr val="6E6E73"/>
-                          </a:solidFill>
-                          <a:latin typeface="Helvetica Neue" pitchFamily="34" charset="0"/>
-                          <a:ea typeface="Helvetica Neue" pitchFamily="34" charset="-122"/>
-                          <a:cs typeface="Helvetica Neue" pitchFamily="34" charset="-120"/>
-                        </a:rPr>
-                        <a:t>Owner</a:t>
-                      </a:r>
-                      <a:endParaRPr lang="en-US" sz="950" dirty="0">
-                        <a:latin typeface="Helvetica Neue" charset="0"/>
-                        <a:ea typeface="Helvetica Neue" charset="0"/>
-                        <a:cs typeface="Helvetica Neue" charset="0"/>
-                      </a:endParaRPr>
-                    </a:p>
-                  </a:txBody>
-                  <a:tcPr marL="5486400" marR="5486400" marT="0" marB="0" anchor="ctr">
-                    <a:lnL w="0" cap="flat" cmpd="sng" algn="ctr">
-                      <a:noFill/>
-                    </a:lnL>
-                    <a:lnR w="0" cap="flat" cmpd="sng" algn="ctr">
-                      <a:noFill/>
-                    </a:lnR>
-                    <a:lnT w="0" cap="flat" cmpd="sng" algn="ctr">
-                      <a:noFill/>
-                    </a:lnT>
-                    <a:lnB w="6350" cap="flat" cmpd="sng" algn="ctr">
-                      <a:solidFill>
-                        <a:srgbClr val="D2D2D7"/>
-                      </a:solidFill>
-                      <a:prstDash val="solid"/>
-                      <a:round/>
-                      <a:headEnd type="none" w="med" len="med"/>
-                      <a:tailEnd type="none" w="med" len="med"/>
-                    </a:lnB>
-                  </a:tcPr>
-                </a:tc>
-                <a:tc>
-                  <a:txBody>
-                    <a:bodyPr/>
-                    <a:lstStyle/>
-                    <a:p>
-                      <a:pPr indent="0" marL="0">
-                        <a:buNone/>
-                      </a:pPr>
-                      <a:r>
-                        <a:rPr lang="en-US" sz="950" dirty="0">
-                          <a:solidFill>
-                            <a:srgbClr val="6E6E73"/>
-                          </a:solidFill>
-                          <a:latin typeface="Helvetica Neue" pitchFamily="34" charset="0"/>
-                          <a:ea typeface="Helvetica Neue" pitchFamily="34" charset="-122"/>
-                          <a:cs typeface="Helvetica Neue" pitchFamily="34" charset="-120"/>
-                        </a:rPr>
-                        <a:t>Analysis</a:t>
-                      </a:r>
-                      <a:endParaRPr lang="en-US" sz="950" dirty="0">
-                        <a:latin typeface="Helvetica Neue" charset="0"/>
-                        <a:ea typeface="Helvetica Neue" charset="0"/>
-                        <a:cs typeface="Helvetica Neue" charset="0"/>
-                      </a:endParaRPr>
-                    </a:p>
-                  </a:txBody>
-                  <a:tcPr marL="5486400" marR="5486400" marT="0" marB="0" anchor="ctr">
-                    <a:lnL w="0" cap="flat" cmpd="sng" algn="ctr">
-                      <a:noFill/>
-                    </a:lnL>
-                    <a:lnR w="0" cap="flat" cmpd="sng" algn="ctr">
-                      <a:noFill/>
-                    </a:lnR>
-                    <a:lnT w="0" cap="flat" cmpd="sng" algn="ctr">
-                      <a:noFill/>
-                    </a:lnT>
-                    <a:lnB w="6350" cap="flat" cmpd="sng" algn="ctr">
-                      <a:solidFill>
-                        <a:srgbClr val="D2D2D7"/>
-                      </a:solidFill>
-                      <a:prstDash val="solid"/>
-                      <a:round/>
-                      <a:headEnd type="none" w="med" len="med"/>
-                      <a:tailEnd type="none" w="med" len="med"/>
-                    </a:lnB>
-                  </a:tcPr>
-                </a:tc>
-                <a:tc>
-                  <a:txBody>
-                    <a:bodyPr/>
-                    <a:lstStyle/>
-                    <a:p>
-                      <a:pPr indent="0" marL="0">
-                        <a:buNone/>
-                      </a:pPr>
-                      <a:r>
-                        <a:rPr lang="en-US" sz="950" dirty="0">
-                          <a:solidFill>
-                            <a:srgbClr val="6E6E73"/>
-                          </a:solidFill>
-                          <a:latin typeface="Helvetica Neue" pitchFamily="34" charset="0"/>
-                          <a:ea typeface="Helvetica Neue" pitchFamily="34" charset="-122"/>
-                          <a:cs typeface="Helvetica Neue" pitchFamily="34" charset="-120"/>
-                        </a:rPr>
-                        <a:t>Two visuals</a:t>
-                      </a:r>
-                      <a:endParaRPr lang="en-US" sz="950" dirty="0">
-                        <a:latin typeface="Helvetica Neue" charset="0"/>
-                        <a:ea typeface="Helvetica Neue" charset="0"/>
-                        <a:cs typeface="Helvetica Neue" charset="0"/>
-                      </a:endParaRPr>
-                    </a:p>
-                  </a:txBody>
-                  <a:tcPr marL="5486400" marR="5486400" marT="0" marB="0" anchor="ctr">
-                    <a:lnL w="0" cap="flat" cmpd="sng" algn="ctr">
-                      <a:noFill/>
-                    </a:lnL>
-                    <a:lnR w="0" cap="flat" cmpd="sng" algn="ctr">
-                      <a:noFill/>
-                    </a:lnR>
-                    <a:lnT w="0" cap="flat" cmpd="sng" algn="ctr">
-                      <a:noFill/>
-                    </a:lnT>
-                    <a:lnB w="6350" cap="flat" cmpd="sng" algn="ctr">
-                      <a:solidFill>
-                        <a:srgbClr val="D2D2D7"/>
-                      </a:solidFill>
-                      <a:prstDash val="solid"/>
-                      <a:round/>
-                      <a:headEnd type="none" w="med" len="med"/>
-                      <a:tailEnd type="none" w="med" len="med"/>
-                    </a:lnB>
-                  </a:tcPr>
-                </a:tc>
-              </a:tr>
-              <a:tr h="438912">
-                <a:tc>
-                  <a:txBody>
-                    <a:bodyPr/>
-                    <a:lstStyle/>
-                    <a:p>
-                      <a:pPr indent="0" marL="0">
-                        <a:buNone/>
-                      </a:pPr>
-                      <a:r>
-                        <a:rPr lang="en-US" sz="1000" b="1" dirty="0">
-                          <a:solidFill>
-                            <a:srgbClr val="1D1D1F"/>
-                          </a:solidFill>
-                          <a:latin typeface="Helvetica Neue" pitchFamily="34" charset="0"/>
-                          <a:ea typeface="Helvetica Neue" pitchFamily="34" charset="-122"/>
-                          <a:cs typeface="Helvetica Neue" pitchFamily="34" charset="-120"/>
-                        </a:rPr>
-                        <a:t>Kaled Dahleh</a:t>
-                      </a:r>
-                      <a:endParaRPr lang="en-US" sz="1000" dirty="0">
-                        <a:latin typeface="Helvetica Neue" charset="0"/>
-                        <a:ea typeface="Helvetica Neue" charset="0"/>
-                        <a:cs typeface="Helvetica Neue" charset="0"/>
-                      </a:endParaRPr>
-                    </a:p>
-                  </a:txBody>
-                  <a:tcPr marL="5486400" marR="5486400" marT="0" marB="0" anchor="ctr">
-                    <a:lnL w="0" cap="flat" cmpd="sng" algn="ctr">
-                      <a:noFill/>
-                    </a:lnL>
-                    <a:lnR w="0" cap="flat" cmpd="sng" algn="ctr">
-                      <a:noFill/>
-                    </a:lnR>
-                    <a:lnT w="0" cap="flat" cmpd="sng" algn="ctr">
-                      <a:noFill/>
-                    </a:lnT>
-                    <a:lnB w="6350" cap="flat" cmpd="sng" algn="ctr">
-                      <a:solidFill>
-                        <a:srgbClr val="D2D2D7"/>
-                      </a:solidFill>
-                      <a:prstDash val="solid"/>
-                      <a:round/>
-                      <a:headEnd type="none" w="med" len="med"/>
-                      <a:tailEnd type="none" w="med" len="med"/>
-                    </a:lnB>
-                  </a:tcPr>
-                </a:tc>
-                <a:tc>
-                  <a:txBody>
-                    <a:bodyPr/>
-                    <a:lstStyle/>
-                    <a:p>
-                      <a:pPr indent="0" marL="0">
-                        <a:buNone/>
-                      </a:pPr>
-                      <a:r>
-                        <a:rPr lang="en-US" sz="1000" dirty="0">
-                          <a:solidFill>
-                            <a:srgbClr val="1D1D1F"/>
-                          </a:solidFill>
-                          <a:latin typeface="Helvetica Neue" pitchFamily="34" charset="0"/>
-                          <a:ea typeface="Helvetica Neue" pitchFamily="34" charset="-122"/>
-                          <a:cs typeface="Helvetica Neue" pitchFamily="34" charset="-120"/>
-                        </a:rPr>
-                        <a:t>Curve fit: expected move vs. strike price</a:t>
-                      </a:r>
-                      <a:endParaRPr lang="en-US" sz="1000" dirty="0">
-                        <a:latin typeface="Helvetica Neue" charset="0"/>
-                        <a:ea typeface="Helvetica Neue" charset="0"/>
-                        <a:cs typeface="Helvetica Neue" charset="0"/>
-                      </a:endParaRPr>
-                    </a:p>
-                  </a:txBody>
-                  <a:tcPr marL="5486400" marR="5486400" marT="0" marB="0" anchor="ctr">
-                    <a:lnL w="0" cap="flat" cmpd="sng" algn="ctr">
-                      <a:noFill/>
-                    </a:lnL>
-                    <a:lnR w="0" cap="flat" cmpd="sng" algn="ctr">
-                      <a:noFill/>
-                    </a:lnR>
-                    <a:lnT w="0" cap="flat" cmpd="sng" algn="ctr">
-                      <a:noFill/>
-                    </a:lnT>
-                    <a:lnB w="6350" cap="flat" cmpd="sng" algn="ctr">
-                      <a:solidFill>
-                        <a:srgbClr val="D2D2D7"/>
-                      </a:solidFill>
-                      <a:prstDash val="solid"/>
-                      <a:round/>
-                      <a:headEnd type="none" w="med" len="med"/>
-                      <a:tailEnd type="none" w="med" len="med"/>
-                    </a:lnB>
-                  </a:tcPr>
-                </a:tc>
-                <a:tc>
-                  <a:txBody>
-                    <a:bodyPr/>
-                    <a:lstStyle/>
-                    <a:p>
-                      <a:pPr indent="0" marL="0">
-                        <a:buNone/>
-                      </a:pPr>
-                      <a:r>
-                        <a:rPr lang="en-US" sz="1000" dirty="0">
-                          <a:solidFill>
-                            <a:srgbClr val="6E6E73"/>
-                          </a:solidFill>
-                          <a:latin typeface="Helvetica Neue" pitchFamily="34" charset="0"/>
-                          <a:ea typeface="Helvetica Neue" pitchFamily="34" charset="-122"/>
-                          <a:cs typeface="Helvetica Neue" pitchFamily="34" charset="-120"/>
-                        </a:rPr>
-                        <a:t>Curve chart; fit vs. actual</a:t>
-                      </a:r>
-                      <a:endParaRPr lang="en-US" sz="1000" dirty="0">
-                        <a:latin typeface="Helvetica Neue" charset="0"/>
-                        <a:ea typeface="Helvetica Neue" charset="0"/>
-                        <a:cs typeface="Helvetica Neue" charset="0"/>
-                      </a:endParaRPr>
-                    </a:p>
-                  </a:txBody>
-                  <a:tcPr marL="5486400" marR="5486400" marT="0" marB="0" anchor="ctr">
-                    <a:lnL w="0" cap="flat" cmpd="sng" algn="ctr">
-                      <a:noFill/>
-                    </a:lnL>
-                    <a:lnR w="0" cap="flat" cmpd="sng" algn="ctr">
-                      <a:noFill/>
-                    </a:lnR>
-                    <a:lnT w="0" cap="flat" cmpd="sng" algn="ctr">
-                      <a:noFill/>
-                    </a:lnT>
-                    <a:lnB w="6350" cap="flat" cmpd="sng" algn="ctr">
-                      <a:solidFill>
-                        <a:srgbClr val="D2D2D7"/>
-                      </a:solidFill>
-                      <a:prstDash val="solid"/>
-                      <a:round/>
-                      <a:headEnd type="none" w="med" len="med"/>
-                      <a:tailEnd type="none" w="med" len="med"/>
-                    </a:lnB>
-                  </a:tcPr>
-                </a:tc>
-              </a:tr>
-              <a:tr h="438912">
-                <a:tc>
-                  <a:txBody>
-                    <a:bodyPr/>
-                    <a:lstStyle/>
-                    <a:p>
-                      <a:pPr indent="0" marL="0">
-                        <a:buNone/>
-                      </a:pPr>
-                      <a:r>
-                        <a:rPr lang="en-US" sz="1000" b="1" dirty="0">
-                          <a:solidFill>
-                            <a:srgbClr val="1D1D1F"/>
-                          </a:solidFill>
-                          <a:latin typeface="Helvetica Neue" pitchFamily="34" charset="0"/>
-                          <a:ea typeface="Helvetica Neue" pitchFamily="34" charset="-122"/>
-                          <a:cs typeface="Helvetica Neue" pitchFamily="34" charset="-120"/>
-                        </a:rPr>
-                        <a:t>Anlil Iwas</a:t>
-                      </a:r>
-                      <a:endParaRPr lang="en-US" sz="1000" dirty="0">
-                        <a:latin typeface="Helvetica Neue" charset="0"/>
-                        <a:ea typeface="Helvetica Neue" charset="0"/>
-                        <a:cs typeface="Helvetica Neue" charset="0"/>
-                      </a:endParaRPr>
-                    </a:p>
-                  </a:txBody>
-                  <a:tcPr marL="5486400" marR="5486400" marT="0" marB="0" anchor="ctr">
-                    <a:lnL w="0" cap="flat" cmpd="sng" algn="ctr">
-                      <a:noFill/>
-                    </a:lnL>
-                    <a:lnR w="0" cap="flat" cmpd="sng" algn="ctr">
-                      <a:noFill/>
-                    </a:lnR>
-                    <a:lnT w="0" cap="flat" cmpd="sng" algn="ctr">
-                      <a:noFill/>
-                    </a:lnT>
-                    <a:lnB w="6350" cap="flat" cmpd="sng" algn="ctr">
-                      <a:solidFill>
-                        <a:srgbClr val="D2D2D7"/>
-                      </a:solidFill>
-                      <a:prstDash val="solid"/>
-                      <a:round/>
-                      <a:headEnd type="none" w="med" len="med"/>
-                      <a:tailEnd type="none" w="med" len="med"/>
-                    </a:lnB>
-                  </a:tcPr>
-                </a:tc>
-                <a:tc>
-                  <a:txBody>
-                    <a:bodyPr/>
-                    <a:lstStyle/>
-                    <a:p>
-                      <a:pPr indent="0" marL="0">
-                        <a:buNone/>
-                      </a:pPr>
-                      <a:r>
-                        <a:rPr lang="en-US" sz="1000" dirty="0">
-                          <a:solidFill>
-                            <a:srgbClr val="1D1D1F"/>
-                          </a:solidFill>
-                          <a:latin typeface="Helvetica Neue" pitchFamily="34" charset="0"/>
-                          <a:ea typeface="Helvetica Neue" pitchFamily="34" charset="-122"/>
-                          <a:cs typeface="Helvetica Neue" pitchFamily="34" charset="-120"/>
-                        </a:rPr>
-                        <a:t>Logistic regression: did traders guess too high?</a:t>
-                      </a:r>
-                      <a:endParaRPr lang="en-US" sz="1000" dirty="0">
-                        <a:latin typeface="Helvetica Neue" charset="0"/>
-                        <a:ea typeface="Helvetica Neue" charset="0"/>
-                        <a:cs typeface="Helvetica Neue" charset="0"/>
-                      </a:endParaRPr>
-                    </a:p>
-                  </a:txBody>
-                  <a:tcPr marL="5486400" marR="5486400" marT="0" marB="0" anchor="ctr">
-                    <a:lnL w="0" cap="flat" cmpd="sng" algn="ctr">
-                      <a:noFill/>
-                    </a:lnL>
-                    <a:lnR w="0" cap="flat" cmpd="sng" algn="ctr">
-                      <a:noFill/>
-                    </a:lnR>
-                    <a:lnT w="0" cap="flat" cmpd="sng" algn="ctr">
-                      <a:noFill/>
-                    </a:lnT>
-                    <a:lnB w="6350" cap="flat" cmpd="sng" algn="ctr">
-                      <a:solidFill>
-                        <a:srgbClr val="D2D2D7"/>
-                      </a:solidFill>
-                      <a:prstDash val="solid"/>
-                      <a:round/>
-                      <a:headEnd type="none" w="med" len="med"/>
-                      <a:tailEnd type="none" w="med" len="med"/>
-                    </a:lnB>
-                  </a:tcPr>
-                </a:tc>
-                <a:tc>
-                  <a:txBody>
-                    <a:bodyPr/>
-                    <a:lstStyle/>
-                    <a:p>
-                      <a:pPr indent="0" marL="0">
-                        <a:buNone/>
-                      </a:pPr>
-                      <a:r>
-                        <a:rPr lang="en-US" sz="1000" dirty="0">
-                          <a:solidFill>
-                            <a:srgbClr val="6E6E73"/>
-                          </a:solidFill>
-                          <a:latin typeface="Helvetica Neue" pitchFamily="34" charset="0"/>
-                          <a:ea typeface="Helvetica Neue" pitchFamily="34" charset="-122"/>
-                          <a:cs typeface="Helvetica Neue" pitchFamily="34" charset="-120"/>
-                        </a:rPr>
-                        <a:t>Expected vs. actual; accuracy by stock</a:t>
-                      </a:r>
-                      <a:endParaRPr lang="en-US" sz="1000" dirty="0">
-                        <a:latin typeface="Helvetica Neue" charset="0"/>
-                        <a:ea typeface="Helvetica Neue" charset="0"/>
-                        <a:cs typeface="Helvetica Neue" charset="0"/>
-                      </a:endParaRPr>
-                    </a:p>
-                  </a:txBody>
-                  <a:tcPr marL="5486400" marR="5486400" marT="0" marB="0" anchor="ctr">
-                    <a:lnL w="0" cap="flat" cmpd="sng" algn="ctr">
-                      <a:noFill/>
-                    </a:lnL>
-                    <a:lnR w="0" cap="flat" cmpd="sng" algn="ctr">
-                      <a:noFill/>
-                    </a:lnR>
-                    <a:lnT w="0" cap="flat" cmpd="sng" algn="ctr">
-                      <a:noFill/>
-                    </a:lnT>
-                    <a:lnB w="6350" cap="flat" cmpd="sng" algn="ctr">
-                      <a:solidFill>
-                        <a:srgbClr val="D2D2D7"/>
-                      </a:solidFill>
-                      <a:prstDash val="solid"/>
-                      <a:round/>
-                      <a:headEnd type="none" w="med" len="med"/>
-                      <a:tailEnd type="none" w="med" len="med"/>
-                    </a:lnB>
-                  </a:tcPr>
-                </a:tc>
-              </a:tr>
-              <a:tr h="438912">
-                <a:tc>
-                  <a:txBody>
-                    <a:bodyPr/>
-                    <a:lstStyle/>
-                    <a:p>
-                      <a:pPr indent="0" marL="0">
-                        <a:buNone/>
-                      </a:pPr>
-                      <a:r>
-                        <a:rPr lang="en-US" sz="1000" b="1" dirty="0">
-                          <a:solidFill>
-                            <a:srgbClr val="1D1D1F"/>
-                          </a:solidFill>
-                          <a:latin typeface="Helvetica Neue" pitchFamily="34" charset="0"/>
-                          <a:ea typeface="Helvetica Neue" pitchFamily="34" charset="-122"/>
-                          <a:cs typeface="Helvetica Neue" pitchFamily="34" charset="-120"/>
-                        </a:rPr>
-                        <a:t>Adi Latic</a:t>
-                      </a:r>
-                      <a:endParaRPr lang="en-US" sz="1000" dirty="0">
-                        <a:latin typeface="Helvetica Neue" charset="0"/>
-                        <a:ea typeface="Helvetica Neue" charset="0"/>
-                        <a:cs typeface="Helvetica Neue" charset="0"/>
-                      </a:endParaRPr>
-                    </a:p>
-                  </a:txBody>
-                  <a:tcPr marL="5486400" marR="5486400" marT="0" marB="0" anchor="ctr">
-                    <a:lnL w="0" cap="flat" cmpd="sng" algn="ctr">
-                      <a:noFill/>
-                    </a:lnL>
-                    <a:lnR w="0" cap="flat" cmpd="sng" algn="ctr">
-                      <a:noFill/>
-                    </a:lnR>
-                    <a:lnT w="0" cap="flat" cmpd="sng" algn="ctr">
-                      <a:noFill/>
-                    </a:lnT>
-                    <a:lnB w="6350" cap="flat" cmpd="sng" algn="ctr">
-                      <a:solidFill>
-                        <a:srgbClr val="D2D2D7"/>
-                      </a:solidFill>
-                      <a:prstDash val="solid"/>
-                      <a:round/>
-                      <a:headEnd type="none" w="med" len="med"/>
-                      <a:tailEnd type="none" w="med" len="med"/>
-                    </a:lnB>
-                  </a:tcPr>
-                </a:tc>
-                <a:tc>
-                  <a:txBody>
-                    <a:bodyPr/>
-                    <a:lstStyle/>
-                    <a:p>
-                      <a:pPr indent="0" marL="0">
-                        <a:buNone/>
-                      </a:pPr>
-                      <a:r>
-                        <a:rPr lang="en-US" sz="1000" dirty="0">
-                          <a:solidFill>
-                            <a:srgbClr val="1D1D1F"/>
-                          </a:solidFill>
-                          <a:latin typeface="Helvetica Neue" pitchFamily="34" charset="0"/>
-                          <a:ea typeface="Helvetica Neue" pitchFamily="34" charset="-122"/>
-                          <a:cs typeface="Helvetica Neue" pitchFamily="34" charset="-120"/>
-                        </a:rPr>
-                        <a:t>Random forest on the same question</a:t>
-                      </a:r>
-                      <a:endParaRPr lang="en-US" sz="1000" dirty="0">
-                        <a:latin typeface="Helvetica Neue" charset="0"/>
-                        <a:ea typeface="Helvetica Neue" charset="0"/>
-                        <a:cs typeface="Helvetica Neue" charset="0"/>
-                      </a:endParaRPr>
-                    </a:p>
-                  </a:txBody>
-                  <a:tcPr marL="5486400" marR="5486400" marT="0" marB="0" anchor="ctr">
-                    <a:lnL w="0" cap="flat" cmpd="sng" algn="ctr">
-                      <a:noFill/>
-                    </a:lnL>
-                    <a:lnR w="0" cap="flat" cmpd="sng" algn="ctr">
-                      <a:noFill/>
-                    </a:lnR>
-                    <a:lnT w="0" cap="flat" cmpd="sng" algn="ctr">
-                      <a:noFill/>
-                    </a:lnT>
-                    <a:lnB w="6350" cap="flat" cmpd="sng" algn="ctr">
-                      <a:solidFill>
-                        <a:srgbClr val="D2D2D7"/>
-                      </a:solidFill>
-                      <a:prstDash val="solid"/>
-                      <a:round/>
-                      <a:headEnd type="none" w="med" len="med"/>
-                      <a:tailEnd type="none" w="med" len="med"/>
-                    </a:lnB>
-                  </a:tcPr>
-                </a:tc>
-                <a:tc>
-                  <a:txBody>
-                    <a:bodyPr/>
-                    <a:lstStyle/>
-                    <a:p>
-                      <a:pPr indent="0" marL="0">
-                        <a:buNone/>
-                      </a:pPr>
-                      <a:r>
-                        <a:rPr lang="en-US" sz="1000" dirty="0">
-                          <a:solidFill>
-                            <a:srgbClr val="6E6E73"/>
-                          </a:solidFill>
-                          <a:latin typeface="Helvetica Neue" pitchFamily="34" charset="0"/>
-                          <a:ea typeface="Helvetica Neue" pitchFamily="34" charset="-122"/>
-                          <a:cs typeface="Helvetica Neue" pitchFamily="34" charset="-120"/>
-                        </a:rPr>
-                        <a:t>What drives the prediction; errors over time</a:t>
-                      </a:r>
-                      <a:endParaRPr lang="en-US" sz="1000" dirty="0">
-                        <a:latin typeface="Helvetica Neue" charset="0"/>
-                        <a:ea typeface="Helvetica Neue" charset="0"/>
-                        <a:cs typeface="Helvetica Neue" charset="0"/>
-                      </a:endParaRPr>
-                    </a:p>
-                  </a:txBody>
-                  <a:tcPr marL="5486400" marR="5486400" marT="0" marB="0" anchor="ctr">
-                    <a:lnL w="0" cap="flat" cmpd="sng" algn="ctr">
-                      <a:noFill/>
-                    </a:lnL>
-                    <a:lnR w="0" cap="flat" cmpd="sng" algn="ctr">
-                      <a:noFill/>
-                    </a:lnR>
-                    <a:lnT w="0" cap="flat" cmpd="sng" algn="ctr">
-                      <a:noFill/>
-                    </a:lnT>
-                    <a:lnB w="6350" cap="flat" cmpd="sng" algn="ctr">
-                      <a:solidFill>
-                        <a:srgbClr val="D2D2D7"/>
-                      </a:solidFill>
-                      <a:prstDash val="solid"/>
-                      <a:round/>
-                      <a:headEnd type="none" w="med" len="med"/>
-                      <a:tailEnd type="none" w="med" len="med"/>
-                    </a:lnB>
-                  </a:tcPr>
-                </a:tc>
-              </a:tr>
-              <a:tr h="438912">
-                <a:tc>
-                  <a:txBody>
-                    <a:bodyPr/>
-                    <a:lstStyle/>
-                    <a:p>
-                      <a:pPr indent="0" marL="0">
-                        <a:buNone/>
-                      </a:pPr>
-                      <a:r>
-                        <a:rPr lang="en-US" sz="1000" b="1" dirty="0">
-                          <a:solidFill>
-                            <a:srgbClr val="1D1D1F"/>
-                          </a:solidFill>
-                          <a:latin typeface="Helvetica Neue" pitchFamily="34" charset="0"/>
-                          <a:ea typeface="Helvetica Neue" pitchFamily="34" charset="-122"/>
-                          <a:cs typeface="Helvetica Neue" pitchFamily="34" charset="-120"/>
-                        </a:rPr>
-                        <a:t>Neo Uy</a:t>
-                      </a:r>
-                      <a:endParaRPr lang="en-US" sz="1000" dirty="0">
-                        <a:latin typeface="Helvetica Neue" charset="0"/>
-                        <a:ea typeface="Helvetica Neue" charset="0"/>
-                        <a:cs typeface="Helvetica Neue" charset="0"/>
-                      </a:endParaRPr>
-                    </a:p>
-                  </a:txBody>
-                  <a:tcPr marL="5486400" marR="5486400" marT="0" marB="0" anchor="ctr">
-                    <a:lnL w="0" cap="flat" cmpd="sng" algn="ctr">
-                      <a:noFill/>
-                    </a:lnL>
-                    <a:lnR w="0" cap="flat" cmpd="sng" algn="ctr">
-                      <a:noFill/>
-                    </a:lnR>
-                    <a:lnT w="0" cap="flat" cmpd="sng" algn="ctr">
-                      <a:noFill/>
-                    </a:lnT>
-                    <a:lnB w="6350" cap="flat" cmpd="sng" algn="ctr">
-                      <a:solidFill>
-                        <a:srgbClr val="D2D2D7"/>
-                      </a:solidFill>
-                      <a:prstDash val="solid"/>
-                      <a:round/>
-                      <a:headEnd type="none" w="med" len="med"/>
-                      <a:tailEnd type="none" w="med" len="med"/>
-                    </a:lnB>
-                  </a:tcPr>
-                </a:tc>
-                <a:tc>
-                  <a:txBody>
-                    <a:bodyPr/>
-                    <a:lstStyle/>
-                    <a:p>
-                      <a:pPr indent="0" marL="0">
-                        <a:buNone/>
-                      </a:pPr>
-                      <a:r>
-                        <a:rPr lang="en-US" sz="1000" dirty="0">
-                          <a:solidFill>
-                            <a:srgbClr val="1D1D1F"/>
-                          </a:solidFill>
-                          <a:latin typeface="Helvetica Neue" pitchFamily="34" charset="0"/>
-                          <a:ea typeface="Helvetica Neue" pitchFamily="34" charset="-122"/>
-                          <a:cs typeface="Helvetica Neue" pitchFamily="34" charset="-120"/>
-                        </a:rPr>
-                        <a:t>Clustering stocks by curve shape</a:t>
-                      </a:r>
-                      <a:endParaRPr lang="en-US" sz="1000" dirty="0">
-                        <a:latin typeface="Helvetica Neue" charset="0"/>
-                        <a:ea typeface="Helvetica Neue" charset="0"/>
-                        <a:cs typeface="Helvetica Neue" charset="0"/>
-                      </a:endParaRPr>
-                    </a:p>
-                  </a:txBody>
-                  <a:tcPr marL="5486400" marR="5486400" marT="0" marB="0" anchor="ctr">
-                    <a:lnL w="0" cap="flat" cmpd="sng" algn="ctr">
-                      <a:noFill/>
-                    </a:lnL>
-                    <a:lnR w="0" cap="flat" cmpd="sng" algn="ctr">
-                      <a:noFill/>
-                    </a:lnR>
-                    <a:lnT w="0" cap="flat" cmpd="sng" algn="ctr">
-                      <a:noFill/>
-                    </a:lnT>
-                    <a:lnB w="6350" cap="flat" cmpd="sng" algn="ctr">
-                      <a:solidFill>
-                        <a:srgbClr val="D2D2D7"/>
-                      </a:solidFill>
-                      <a:prstDash val="solid"/>
-                      <a:round/>
-                      <a:headEnd type="none" w="med" len="med"/>
-                      <a:tailEnd type="none" w="med" len="med"/>
-                    </a:lnB>
-                  </a:tcPr>
-                </a:tc>
-                <a:tc>
-                  <a:txBody>
-                    <a:bodyPr/>
-                    <a:lstStyle/>
-                    <a:p>
-                      <a:pPr indent="0" marL="0">
-                        <a:buNone/>
-                      </a:pPr>
-                      <a:r>
-                        <a:rPr lang="en-US" sz="1000" dirty="0">
-                          <a:solidFill>
-                            <a:srgbClr val="6E6E73"/>
-                          </a:solidFill>
-                          <a:latin typeface="Helvetica Neue" pitchFamily="34" charset="0"/>
-                          <a:ea typeface="Helvetica Neue" pitchFamily="34" charset="-122"/>
-                          <a:cs typeface="Helvetica Neue" pitchFamily="34" charset="-120"/>
-                        </a:rPr>
-                        <a:t>Cluster map; curves by group</a:t>
-                      </a:r>
-                      <a:endParaRPr lang="en-US" sz="1000" dirty="0">
-                        <a:latin typeface="Helvetica Neue" charset="0"/>
-                        <a:ea typeface="Helvetica Neue" charset="0"/>
-                        <a:cs typeface="Helvetica Neue" charset="0"/>
-                      </a:endParaRPr>
-                    </a:p>
-                  </a:txBody>
-                  <a:tcPr marL="5486400" marR="5486400" marT="0" marB="0" anchor="ctr">
-                    <a:lnL w="0" cap="flat" cmpd="sng" algn="ctr">
-                      <a:noFill/>
-                    </a:lnL>
-                    <a:lnR w="0" cap="flat" cmpd="sng" algn="ctr">
-                      <a:noFill/>
-                    </a:lnR>
-                    <a:lnT w="0" cap="flat" cmpd="sng" algn="ctr">
-                      <a:noFill/>
-                    </a:lnT>
-                    <a:lnB w="6350" cap="flat" cmpd="sng" algn="ctr">
-                      <a:solidFill>
-                        <a:srgbClr val="D2D2D7"/>
-                      </a:solidFill>
-                      <a:prstDash val="solid"/>
-                      <a:round/>
-                      <a:headEnd type="none" w="med" len="med"/>
-                      <a:tailEnd type="none" w="med" len="med"/>
-                    </a:lnB>
-                  </a:tcPr>
-                </a:tc>
-              </a:tr>
-              <a:tr h="438912">
-                <a:tc>
-                  <a:txBody>
-                    <a:bodyPr/>
-                    <a:lstStyle/>
-                    <a:p>
-                      <a:pPr indent="0" marL="0">
-                        <a:buNone/>
-                      </a:pPr>
-                      <a:r>
-                        <a:rPr lang="en-US" sz="1000" b="1" dirty="0">
-                          <a:solidFill>
-                            <a:srgbClr val="1D1D1F"/>
-                          </a:solidFill>
-                          <a:latin typeface="Helvetica Neue" pitchFamily="34" charset="0"/>
-                          <a:ea typeface="Helvetica Neue" pitchFamily="34" charset="-122"/>
-                          <a:cs typeface="Helvetica Neue" pitchFamily="34" charset="-120"/>
-                        </a:rPr>
-                        <a:t>Musa Tabally</a:t>
-                      </a:r>
-                      <a:endParaRPr lang="en-US" sz="1000" dirty="0">
-                        <a:latin typeface="Helvetica Neue" charset="0"/>
-                        <a:ea typeface="Helvetica Neue" charset="0"/>
-                        <a:cs typeface="Helvetica Neue" charset="0"/>
-                      </a:endParaRPr>
-                    </a:p>
-                  </a:txBody>
-                  <a:tcPr marL="5486400" marR="5486400" marT="0" marB="0" anchor="ctr">
-                    <a:lnL w="0" cap="flat" cmpd="sng" algn="ctr">
-                      <a:noFill/>
-                    </a:lnL>
-                    <a:lnR w="0" cap="flat" cmpd="sng" algn="ctr">
-                      <a:noFill/>
-                    </a:lnR>
-                    <a:lnT w="0" cap="flat" cmpd="sng" algn="ctr">
-                      <a:noFill/>
-                    </a:lnT>
-                    <a:lnB w="0" cap="flat" cmpd="sng" algn="ctr">
-                      <a:noFill/>
-                    </a:lnB>
-                  </a:tcPr>
-                </a:tc>
-                <a:tc>
-                  <a:txBody>
-                    <a:bodyPr/>
-                    <a:lstStyle/>
-                    <a:p>
-                      <a:pPr indent="0" marL="0">
-                        <a:buNone/>
-                      </a:pPr>
-                      <a:r>
-                        <a:rPr lang="en-US" sz="1000" dirty="0">
-                          <a:solidFill>
-                            <a:srgbClr val="1D1D1F"/>
-                          </a:solidFill>
-                          <a:latin typeface="Helvetica Neue" pitchFamily="34" charset="0"/>
-                          <a:ea typeface="Helvetica Neue" pitchFamily="34" charset="-122"/>
-                          <a:cs typeface="Helvetica Neue" pitchFamily="34" charset="-120"/>
-                        </a:rPr>
-                        <a:t>Statistical test: expected vs. actual</a:t>
-                      </a:r>
-                      <a:endParaRPr lang="en-US" sz="1000" dirty="0">
-                        <a:latin typeface="Helvetica Neue" charset="0"/>
-                        <a:ea typeface="Helvetica Neue" charset="0"/>
-                        <a:cs typeface="Helvetica Neue" charset="0"/>
-                      </a:endParaRPr>
-                    </a:p>
-                  </a:txBody>
-                  <a:tcPr marL="5486400" marR="5486400" marT="0" marB="0" anchor="ctr">
-                    <a:lnL w="0" cap="flat" cmpd="sng" algn="ctr">
-                      <a:noFill/>
-                    </a:lnL>
-                    <a:lnR w="0" cap="flat" cmpd="sng" algn="ctr">
-                      <a:noFill/>
-                    </a:lnR>
-                    <a:lnT w="0" cap="flat" cmpd="sng" algn="ctr">
-                      <a:noFill/>
-                    </a:lnT>
-                    <a:lnB w="0" cap="flat" cmpd="sng" algn="ctr">
-                      <a:noFill/>
-                    </a:lnB>
-                  </a:tcPr>
-                </a:tc>
-                <a:tc>
-                  <a:txBody>
-                    <a:bodyPr/>
-                    <a:lstStyle/>
-                    <a:p>
-                      <a:pPr indent="0" marL="0">
-                        <a:buNone/>
-                      </a:pPr>
-                      <a:r>
-                        <a:rPr lang="en-US" sz="1000" dirty="0">
-                          <a:solidFill>
-                            <a:srgbClr val="6E6E73"/>
-                          </a:solidFill>
-                          <a:latin typeface="Helvetica Neue" pitchFamily="34" charset="0"/>
-                          <a:ea typeface="Helvetica Neue" pitchFamily="34" charset="-122"/>
-                          <a:cs typeface="Helvetica Neue" pitchFamily="34" charset="-120"/>
-                        </a:rPr>
-                        <a:t>Gap over time; heatmap by month</a:t>
-                      </a:r>
-                      <a:endParaRPr lang="en-US" sz="1000" dirty="0">
-                        <a:latin typeface="Helvetica Neue" charset="0"/>
-                        <a:ea typeface="Helvetica Neue" charset="0"/>
-                        <a:cs typeface="Helvetica Neue" charset="0"/>
-                      </a:endParaRPr>
-                    </a:p>
-                  </a:txBody>
-                  <a:tcPr marL="5486400" marR="5486400" marT="0" marB="0" anchor="ctr">
-                    <a:lnL w="0" cap="flat" cmpd="sng" algn="ctr">
-                      <a:noFill/>
-                    </a:lnL>
-                    <a:lnR w="0" cap="flat" cmpd="sng" algn="ctr">
-                      <a:noFill/>
-                    </a:lnR>
-                    <a:lnT w="0" cap="flat" cmpd="sng" algn="ctr">
-                      <a:noFill/>
-                    </a:lnT>
-                    <a:lnB w="0" cap="flat" cmpd="sng" algn="ctr">
-                      <a:noFill/>
-                    </a:lnB>
-                  </a:tcPr>
-                </a:tc>
-              </a:tr>
-            </a:tbl>
-          </a:graphicData>
-        </a:graphic>
-      </p:graphicFrame>
-      <p:sp>
-        <p:nvSpPr>
-          <p:cNvPr id="17" name="Text 14"/>
-          <p:cNvSpPr txBox="1"/>
-          <p:nvPr/>
-        </p:nvSpPr>
-        <p:spPr>
-          <a:xfrm>
-            <a:off x="4114800" y="4315968"/>
+      <p:sp>
+        <p:nvSpPr>
+          <p:cNvPr id="16" name="Text 14"/>
+          <p:cNvSpPr txBox="1"/>
+          <p:nvPr/>
+        </p:nvSpPr>
+        <p:spPr>
+          <a:xfrm>
+            <a:off x="4069080" y="1554480"/>
+            <a:ext cx="914400" cy="182880"/>
+          </a:xfrm>
+          <a:prstGeom prst="rect">
+            <a:avLst/>
+          </a:prstGeom>
+          <a:noFill/>
+          <a:ln/>
+        </p:spPr>
+        <p:txBody>
+          <a:bodyPr wrap="square" lIns="0" tIns="0" rIns="0" bIns="0" rtlCol="0" anchor="t"/>
+          <a:lstStyle/>
+          <a:p>
+            <a:pPr indent="0" marL="0">
+              <a:buNone/>
+            </a:pPr>
+            <a:r>
+              <a:rPr lang="en-US" sz="950" dirty="0">
+                <a:solidFill>
+                  <a:srgbClr val="6E6E73"/>
+                </a:solidFill>
+                <a:latin typeface="Helvetica Neue" pitchFamily="34" charset="0"/>
+                <a:ea typeface="Helvetica Neue" pitchFamily="34" charset="-122"/>
+                <a:cs typeface="Helvetica Neue" pitchFamily="34" charset="-120"/>
+              </a:rPr>
+              <a:t>Owner</a:t>
+            </a:r>
+            <a:endParaRPr lang="en-US" sz="950" dirty="0"/>
+          </a:p>
+        </p:txBody>
+      </p:sp>
+      <p:sp>
+        <p:nvSpPr>
+          <p:cNvPr id="17" name="Text 15"/>
+          <p:cNvSpPr txBox="1"/>
+          <p:nvPr/>
+        </p:nvSpPr>
+        <p:spPr>
+          <a:xfrm>
+            <a:off x="5029200" y="1554480"/>
+            <a:ext cx="1554480" cy="182880"/>
+          </a:xfrm>
+          <a:prstGeom prst="rect">
+            <a:avLst/>
+          </a:prstGeom>
+          <a:noFill/>
+          <a:ln/>
+        </p:spPr>
+        <p:txBody>
+          <a:bodyPr wrap="square" lIns="0" tIns="0" rIns="0" bIns="0" rtlCol="0" anchor="t"/>
+          <a:lstStyle/>
+          <a:p>
+            <a:pPr indent="0" marL="0">
+              <a:buNone/>
+            </a:pPr>
+            <a:r>
+              <a:rPr lang="en-US" sz="950" dirty="0">
+                <a:solidFill>
+                  <a:srgbClr val="6E6E73"/>
+                </a:solidFill>
+                <a:latin typeface="Helvetica Neue" pitchFamily="34" charset="0"/>
+                <a:ea typeface="Helvetica Neue" pitchFamily="34" charset="-122"/>
+                <a:cs typeface="Helvetica Neue" pitchFamily="34" charset="-120"/>
+              </a:rPr>
+              <a:t>Analysis</a:t>
+            </a:r>
+            <a:endParaRPr lang="en-US" sz="950" dirty="0"/>
+          </a:p>
+        </p:txBody>
+      </p:sp>
+      <p:sp>
+        <p:nvSpPr>
+          <p:cNvPr id="18" name="Text 16"/>
+          <p:cNvSpPr txBox="1"/>
+          <p:nvPr/>
+        </p:nvSpPr>
+        <p:spPr>
+          <a:xfrm>
+            <a:off x="6675120" y="1554480"/>
+            <a:ext cx="1783080" cy="182880"/>
+          </a:xfrm>
+          <a:prstGeom prst="rect">
+            <a:avLst/>
+          </a:prstGeom>
+          <a:noFill/>
+          <a:ln/>
+        </p:spPr>
+        <p:txBody>
+          <a:bodyPr wrap="square" lIns="0" tIns="0" rIns="0" bIns="0" rtlCol="0" anchor="t"/>
+          <a:lstStyle/>
+          <a:p>
+            <a:pPr indent="0" marL="0">
+              <a:buNone/>
+            </a:pPr>
+            <a:r>
+              <a:rPr lang="en-US" sz="950" dirty="0">
+                <a:solidFill>
+                  <a:srgbClr val="6E6E73"/>
+                </a:solidFill>
+                <a:latin typeface="Helvetica Neue" pitchFamily="34" charset="0"/>
+                <a:ea typeface="Helvetica Neue" pitchFamily="34" charset="-122"/>
+                <a:cs typeface="Helvetica Neue" pitchFamily="34" charset="-120"/>
+              </a:rPr>
+              <a:t>Two visuals</a:t>
+            </a:r>
+            <a:endParaRPr lang="en-US" sz="950" dirty="0"/>
+          </a:p>
+        </p:txBody>
+      </p:sp>
+      <p:sp>
+        <p:nvSpPr>
+          <p:cNvPr id="19" name="Shape 17"/>
+          <p:cNvSpPr/>
+          <p:nvPr/>
+        </p:nvSpPr>
+        <p:spPr>
+          <a:xfrm>
+            <a:off x="4069080" y="1801368"/>
+            <a:ext cx="4343400" cy="0"/>
+          </a:xfrm>
+          <a:prstGeom prst="line">
+            <a:avLst/>
+          </a:prstGeom>
+          <a:noFill/>
+          <a:ln w="6350">
+            <a:solidFill>
+              <a:srgbClr val="D2D2D7"/>
+            </a:solidFill>
+            <a:prstDash val="solid"/>
+          </a:ln>
+        </p:spPr>
+      </p:sp>
+      <p:sp>
+        <p:nvSpPr>
+          <p:cNvPr id="20" name="Text 18"/>
+          <p:cNvSpPr txBox="1"/>
+          <p:nvPr/>
+        </p:nvSpPr>
+        <p:spPr>
+          <a:xfrm>
+            <a:off x="4069080" y="1874520"/>
+            <a:ext cx="914400" cy="384048"/>
+          </a:xfrm>
+          <a:prstGeom prst="rect">
+            <a:avLst/>
+          </a:prstGeom>
+          <a:noFill/>
+          <a:ln/>
+        </p:spPr>
+        <p:txBody>
+          <a:bodyPr wrap="square" lIns="0" tIns="0" rIns="0" bIns="0" rtlCol="0" anchor="ctr"/>
+          <a:lstStyle/>
+          <a:p>
+            <a:pPr indent="0" marL="0">
+              <a:buNone/>
+            </a:pPr>
+            <a:r>
+              <a:rPr lang="en-US" sz="1000" b="1" dirty="0">
+                <a:solidFill>
+                  <a:srgbClr val="1D1D1F"/>
+                </a:solidFill>
+                <a:latin typeface="Helvetica Neue" pitchFamily="34" charset="0"/>
+                <a:ea typeface="Helvetica Neue" pitchFamily="34" charset="-122"/>
+                <a:cs typeface="Helvetica Neue" pitchFamily="34" charset="-120"/>
+              </a:rPr>
+              <a:t>Kaled Dahleh</a:t>
+            </a:r>
+            <a:endParaRPr lang="en-US" sz="1000" dirty="0"/>
+          </a:p>
+        </p:txBody>
+      </p:sp>
+      <p:sp>
+        <p:nvSpPr>
+          <p:cNvPr id="21" name="Text 19"/>
+          <p:cNvSpPr txBox="1"/>
+          <p:nvPr/>
+        </p:nvSpPr>
+        <p:spPr>
+          <a:xfrm>
+            <a:off x="5029200" y="1874520"/>
+            <a:ext cx="1554480" cy="384048"/>
+          </a:xfrm>
+          <a:prstGeom prst="rect">
+            <a:avLst/>
+          </a:prstGeom>
+          <a:noFill/>
+          <a:ln/>
+        </p:spPr>
+        <p:txBody>
+          <a:bodyPr wrap="square" lIns="0" tIns="0" rIns="0" bIns="0" rtlCol="0" anchor="ctr"/>
+          <a:lstStyle/>
+          <a:p>
+            <a:pPr indent="0" marL="0">
+              <a:buNone/>
+            </a:pPr>
+            <a:r>
+              <a:rPr lang="en-US" sz="1000" dirty="0">
+                <a:solidFill>
+                  <a:srgbClr val="1D1D1F"/>
+                </a:solidFill>
+                <a:latin typeface="Helvetica Neue" pitchFamily="34" charset="0"/>
+                <a:ea typeface="Helvetica Neue" pitchFamily="34" charset="-122"/>
+                <a:cs typeface="Helvetica Neue" pitchFamily="34" charset="-120"/>
+              </a:rPr>
+              <a:t>Curve fit: expected move vs. strike price</a:t>
+            </a:r>
+            <a:endParaRPr lang="en-US" sz="1000" dirty="0"/>
+          </a:p>
+        </p:txBody>
+      </p:sp>
+      <p:sp>
+        <p:nvSpPr>
+          <p:cNvPr id="22" name="Text 20"/>
+          <p:cNvSpPr txBox="1"/>
+          <p:nvPr/>
+        </p:nvSpPr>
+        <p:spPr>
+          <a:xfrm>
+            <a:off x="6675120" y="1874520"/>
+            <a:ext cx="1783080" cy="384048"/>
+          </a:xfrm>
+          <a:prstGeom prst="rect">
+            <a:avLst/>
+          </a:prstGeom>
+          <a:noFill/>
+          <a:ln/>
+        </p:spPr>
+        <p:txBody>
+          <a:bodyPr wrap="square" lIns="0" tIns="0" rIns="0" bIns="0" rtlCol="0" anchor="ctr"/>
+          <a:lstStyle/>
+          <a:p>
+            <a:pPr indent="0" marL="0">
+              <a:buNone/>
+            </a:pPr>
+            <a:r>
+              <a:rPr lang="en-US" sz="950" dirty="0">
+                <a:solidFill>
+                  <a:srgbClr val="6E6E73"/>
+                </a:solidFill>
+                <a:latin typeface="Helvetica Neue" pitchFamily="34" charset="0"/>
+                <a:ea typeface="Helvetica Neue" pitchFamily="34" charset="-122"/>
+                <a:cs typeface="Helvetica Neue" pitchFamily="34" charset="-120"/>
+              </a:rPr>
+              <a:t>Curve chart; fit vs. actual</a:t>
+            </a:r>
+            <a:endParaRPr lang="en-US" sz="950" dirty="0"/>
+          </a:p>
+        </p:txBody>
+      </p:sp>
+      <p:sp>
+        <p:nvSpPr>
+          <p:cNvPr id="23" name="Shape 21"/>
+          <p:cNvSpPr/>
+          <p:nvPr/>
+        </p:nvSpPr>
+        <p:spPr>
+          <a:xfrm>
+            <a:off x="4069080" y="2304288"/>
+            <a:ext cx="4343400" cy="0"/>
+          </a:xfrm>
+          <a:prstGeom prst="line">
+            <a:avLst/>
+          </a:prstGeom>
+          <a:noFill/>
+          <a:ln w="6350">
+            <a:solidFill>
+              <a:srgbClr val="D2D2D7"/>
+            </a:solidFill>
+            <a:prstDash val="solid"/>
+          </a:ln>
+        </p:spPr>
+      </p:sp>
+      <p:sp>
+        <p:nvSpPr>
+          <p:cNvPr id="24" name="Text 22"/>
+          <p:cNvSpPr txBox="1"/>
+          <p:nvPr/>
+        </p:nvSpPr>
+        <p:spPr>
+          <a:xfrm>
+            <a:off x="4069080" y="2350008"/>
+            <a:ext cx="914400" cy="384048"/>
+          </a:xfrm>
+          <a:prstGeom prst="rect">
+            <a:avLst/>
+          </a:prstGeom>
+          <a:noFill/>
+          <a:ln/>
+        </p:spPr>
+        <p:txBody>
+          <a:bodyPr wrap="square" lIns="0" tIns="0" rIns="0" bIns="0" rtlCol="0" anchor="ctr"/>
+          <a:lstStyle/>
+          <a:p>
+            <a:pPr indent="0" marL="0">
+              <a:buNone/>
+            </a:pPr>
+            <a:r>
+              <a:rPr lang="en-US" sz="1000" b="1" dirty="0">
+                <a:solidFill>
+                  <a:srgbClr val="1D1D1F"/>
+                </a:solidFill>
+                <a:latin typeface="Helvetica Neue" pitchFamily="34" charset="0"/>
+                <a:ea typeface="Helvetica Neue" pitchFamily="34" charset="-122"/>
+                <a:cs typeface="Helvetica Neue" pitchFamily="34" charset="-120"/>
+              </a:rPr>
+              <a:t>Anlil Iwas</a:t>
+            </a:r>
+            <a:endParaRPr lang="en-US" sz="1000" dirty="0"/>
+          </a:p>
+        </p:txBody>
+      </p:sp>
+      <p:sp>
+        <p:nvSpPr>
+          <p:cNvPr id="25" name="Text 23"/>
+          <p:cNvSpPr txBox="1"/>
+          <p:nvPr/>
+        </p:nvSpPr>
+        <p:spPr>
+          <a:xfrm>
+            <a:off x="5029200" y="2350008"/>
+            <a:ext cx="1554480" cy="384048"/>
+          </a:xfrm>
+          <a:prstGeom prst="rect">
+            <a:avLst/>
+          </a:prstGeom>
+          <a:noFill/>
+          <a:ln/>
+        </p:spPr>
+        <p:txBody>
+          <a:bodyPr wrap="square" lIns="0" tIns="0" rIns="0" bIns="0" rtlCol="0" anchor="ctr"/>
+          <a:lstStyle/>
+          <a:p>
+            <a:pPr indent="0" marL="0">
+              <a:buNone/>
+            </a:pPr>
+            <a:r>
+              <a:rPr lang="en-US" sz="1000" dirty="0">
+                <a:solidFill>
+                  <a:srgbClr val="1D1D1F"/>
+                </a:solidFill>
+                <a:latin typeface="Helvetica Neue" pitchFamily="34" charset="0"/>
+                <a:ea typeface="Helvetica Neue" pitchFamily="34" charset="-122"/>
+                <a:cs typeface="Helvetica Neue" pitchFamily="34" charset="-120"/>
+              </a:rPr>
+              <a:t>Logistic regression: did traders guess too high?</a:t>
+            </a:r>
+            <a:endParaRPr lang="en-US" sz="1000" dirty="0"/>
+          </a:p>
+        </p:txBody>
+      </p:sp>
+      <p:sp>
+        <p:nvSpPr>
+          <p:cNvPr id="26" name="Text 24"/>
+          <p:cNvSpPr txBox="1"/>
+          <p:nvPr/>
+        </p:nvSpPr>
+        <p:spPr>
+          <a:xfrm>
+            <a:off x="6675120" y="2350008"/>
+            <a:ext cx="1783080" cy="384048"/>
+          </a:xfrm>
+          <a:prstGeom prst="rect">
+            <a:avLst/>
+          </a:prstGeom>
+          <a:noFill/>
+          <a:ln/>
+        </p:spPr>
+        <p:txBody>
+          <a:bodyPr wrap="square" lIns="0" tIns="0" rIns="0" bIns="0" rtlCol="0" anchor="ctr"/>
+          <a:lstStyle/>
+          <a:p>
+            <a:pPr indent="0" marL="0">
+              <a:buNone/>
+            </a:pPr>
+            <a:r>
+              <a:rPr lang="en-US" sz="950" dirty="0">
+                <a:solidFill>
+                  <a:srgbClr val="6E6E73"/>
+                </a:solidFill>
+                <a:latin typeface="Helvetica Neue" pitchFamily="34" charset="0"/>
+                <a:ea typeface="Helvetica Neue" pitchFamily="34" charset="-122"/>
+                <a:cs typeface="Helvetica Neue" pitchFamily="34" charset="-120"/>
+              </a:rPr>
+              <a:t>Expected vs. actual; accuracy by stock</a:t>
+            </a:r>
+            <a:endParaRPr lang="en-US" sz="950" dirty="0"/>
+          </a:p>
+        </p:txBody>
+      </p:sp>
+      <p:sp>
+        <p:nvSpPr>
+          <p:cNvPr id="27" name="Shape 25"/>
+          <p:cNvSpPr/>
+          <p:nvPr/>
+        </p:nvSpPr>
+        <p:spPr>
+          <a:xfrm>
+            <a:off x="4069080" y="2779776"/>
+            <a:ext cx="4343400" cy="0"/>
+          </a:xfrm>
+          <a:prstGeom prst="line">
+            <a:avLst/>
+          </a:prstGeom>
+          <a:noFill/>
+          <a:ln w="6350">
+            <a:solidFill>
+              <a:srgbClr val="D2D2D7"/>
+            </a:solidFill>
+            <a:prstDash val="solid"/>
+          </a:ln>
+        </p:spPr>
+      </p:sp>
+      <p:sp>
+        <p:nvSpPr>
+          <p:cNvPr id="28" name="Text 26"/>
+          <p:cNvSpPr txBox="1"/>
+          <p:nvPr/>
+        </p:nvSpPr>
+        <p:spPr>
+          <a:xfrm>
+            <a:off x="4069080" y="2825496"/>
+            <a:ext cx="914400" cy="384048"/>
+          </a:xfrm>
+          <a:prstGeom prst="rect">
+            <a:avLst/>
+          </a:prstGeom>
+          <a:noFill/>
+          <a:ln/>
+        </p:spPr>
+        <p:txBody>
+          <a:bodyPr wrap="square" lIns="0" tIns="0" rIns="0" bIns="0" rtlCol="0" anchor="ctr"/>
+          <a:lstStyle/>
+          <a:p>
+            <a:pPr indent="0" marL="0">
+              <a:buNone/>
+            </a:pPr>
+            <a:r>
+              <a:rPr lang="en-US" sz="1000" b="1" dirty="0">
+                <a:solidFill>
+                  <a:srgbClr val="1D1D1F"/>
+                </a:solidFill>
+                <a:latin typeface="Helvetica Neue" pitchFamily="34" charset="0"/>
+                <a:ea typeface="Helvetica Neue" pitchFamily="34" charset="-122"/>
+                <a:cs typeface="Helvetica Neue" pitchFamily="34" charset="-120"/>
+              </a:rPr>
+              <a:t>Adi Latic</a:t>
+            </a:r>
+            <a:endParaRPr lang="en-US" sz="1000" dirty="0"/>
+          </a:p>
+        </p:txBody>
+      </p:sp>
+      <p:sp>
+        <p:nvSpPr>
+          <p:cNvPr id="29" name="Text 27"/>
+          <p:cNvSpPr txBox="1"/>
+          <p:nvPr/>
+        </p:nvSpPr>
+        <p:spPr>
+          <a:xfrm>
+            <a:off x="5029200" y="2825496"/>
+            <a:ext cx="1554480" cy="384048"/>
+          </a:xfrm>
+          <a:prstGeom prst="rect">
+            <a:avLst/>
+          </a:prstGeom>
+          <a:noFill/>
+          <a:ln/>
+        </p:spPr>
+        <p:txBody>
+          <a:bodyPr wrap="square" lIns="0" tIns="0" rIns="0" bIns="0" rtlCol="0" anchor="ctr"/>
+          <a:lstStyle/>
+          <a:p>
+            <a:pPr indent="0" marL="0">
+              <a:buNone/>
+            </a:pPr>
+            <a:r>
+              <a:rPr lang="en-US" sz="1000" dirty="0">
+                <a:solidFill>
+                  <a:srgbClr val="1D1D1F"/>
+                </a:solidFill>
+                <a:latin typeface="Helvetica Neue" pitchFamily="34" charset="0"/>
+                <a:ea typeface="Helvetica Neue" pitchFamily="34" charset="-122"/>
+                <a:cs typeface="Helvetica Neue" pitchFamily="34" charset="-120"/>
+              </a:rPr>
+              <a:t>Random forest on the same question</a:t>
+            </a:r>
+            <a:endParaRPr lang="en-US" sz="1000" dirty="0"/>
+          </a:p>
+        </p:txBody>
+      </p:sp>
+      <p:sp>
+        <p:nvSpPr>
+          <p:cNvPr id="30" name="Text 28"/>
+          <p:cNvSpPr txBox="1"/>
+          <p:nvPr/>
+        </p:nvSpPr>
+        <p:spPr>
+          <a:xfrm>
+            <a:off x="6675120" y="2825496"/>
+            <a:ext cx="1783080" cy="384048"/>
+          </a:xfrm>
+          <a:prstGeom prst="rect">
+            <a:avLst/>
+          </a:prstGeom>
+          <a:noFill/>
+          <a:ln/>
+        </p:spPr>
+        <p:txBody>
+          <a:bodyPr wrap="square" lIns="0" tIns="0" rIns="0" bIns="0" rtlCol="0" anchor="ctr"/>
+          <a:lstStyle/>
+          <a:p>
+            <a:pPr indent="0" marL="0">
+              <a:buNone/>
+            </a:pPr>
+            <a:r>
+              <a:rPr lang="en-US" sz="950" dirty="0">
+                <a:solidFill>
+                  <a:srgbClr val="6E6E73"/>
+                </a:solidFill>
+                <a:latin typeface="Helvetica Neue" pitchFamily="34" charset="0"/>
+                <a:ea typeface="Helvetica Neue" pitchFamily="34" charset="-122"/>
+                <a:cs typeface="Helvetica Neue" pitchFamily="34" charset="-120"/>
+              </a:rPr>
+              <a:t>What drives the prediction; errors over time</a:t>
+            </a:r>
+            <a:endParaRPr lang="en-US" sz="950" dirty="0"/>
+          </a:p>
+        </p:txBody>
+      </p:sp>
+      <p:sp>
+        <p:nvSpPr>
+          <p:cNvPr id="31" name="Shape 29"/>
+          <p:cNvSpPr/>
+          <p:nvPr/>
+        </p:nvSpPr>
+        <p:spPr>
+          <a:xfrm>
+            <a:off x="4069080" y="3255264"/>
+            <a:ext cx="4343400" cy="0"/>
+          </a:xfrm>
+          <a:prstGeom prst="line">
+            <a:avLst/>
+          </a:prstGeom>
+          <a:noFill/>
+          <a:ln w="6350">
+            <a:solidFill>
+              <a:srgbClr val="D2D2D7"/>
+            </a:solidFill>
+            <a:prstDash val="solid"/>
+          </a:ln>
+        </p:spPr>
+      </p:sp>
+      <p:sp>
+        <p:nvSpPr>
+          <p:cNvPr id="32" name="Text 30"/>
+          <p:cNvSpPr txBox="1"/>
+          <p:nvPr/>
+        </p:nvSpPr>
+        <p:spPr>
+          <a:xfrm>
+            <a:off x="4069080" y="3300984"/>
+            <a:ext cx="914400" cy="384048"/>
+          </a:xfrm>
+          <a:prstGeom prst="rect">
+            <a:avLst/>
+          </a:prstGeom>
+          <a:noFill/>
+          <a:ln/>
+        </p:spPr>
+        <p:txBody>
+          <a:bodyPr wrap="square" lIns="0" tIns="0" rIns="0" bIns="0" rtlCol="0" anchor="ctr"/>
+          <a:lstStyle/>
+          <a:p>
+            <a:pPr indent="0" marL="0">
+              <a:buNone/>
+            </a:pPr>
+            <a:r>
+              <a:rPr lang="en-US" sz="1000" b="1" dirty="0">
+                <a:solidFill>
+                  <a:srgbClr val="1D1D1F"/>
+                </a:solidFill>
+                <a:latin typeface="Helvetica Neue" pitchFamily="34" charset="0"/>
+                <a:ea typeface="Helvetica Neue" pitchFamily="34" charset="-122"/>
+                <a:cs typeface="Helvetica Neue" pitchFamily="34" charset="-120"/>
+              </a:rPr>
+              <a:t>Neo Uy</a:t>
+            </a:r>
+            <a:endParaRPr lang="en-US" sz="1000" dirty="0"/>
+          </a:p>
+        </p:txBody>
+      </p:sp>
+      <p:sp>
+        <p:nvSpPr>
+          <p:cNvPr id="33" name="Text 31"/>
+          <p:cNvSpPr txBox="1"/>
+          <p:nvPr/>
+        </p:nvSpPr>
+        <p:spPr>
+          <a:xfrm>
+            <a:off x="5029200" y="3300984"/>
+            <a:ext cx="1554480" cy="384048"/>
+          </a:xfrm>
+          <a:prstGeom prst="rect">
+            <a:avLst/>
+          </a:prstGeom>
+          <a:noFill/>
+          <a:ln/>
+        </p:spPr>
+        <p:txBody>
+          <a:bodyPr wrap="square" lIns="0" tIns="0" rIns="0" bIns="0" rtlCol="0" anchor="ctr"/>
+          <a:lstStyle/>
+          <a:p>
+            <a:pPr indent="0" marL="0">
+              <a:buNone/>
+            </a:pPr>
+            <a:r>
+              <a:rPr lang="en-US" sz="1000" dirty="0">
+                <a:solidFill>
+                  <a:srgbClr val="1D1D1F"/>
+                </a:solidFill>
+                <a:latin typeface="Helvetica Neue" pitchFamily="34" charset="0"/>
+                <a:ea typeface="Helvetica Neue" pitchFamily="34" charset="-122"/>
+                <a:cs typeface="Helvetica Neue" pitchFamily="34" charset="-120"/>
+              </a:rPr>
+              <a:t>Clustering stocks by curve shape</a:t>
+            </a:r>
+            <a:endParaRPr lang="en-US" sz="1000" dirty="0"/>
+          </a:p>
+        </p:txBody>
+      </p:sp>
+      <p:sp>
+        <p:nvSpPr>
+          <p:cNvPr id="34" name="Text 32"/>
+          <p:cNvSpPr txBox="1"/>
+          <p:nvPr/>
+        </p:nvSpPr>
+        <p:spPr>
+          <a:xfrm>
+            <a:off x="6675120" y="3300984"/>
+            <a:ext cx="1783080" cy="384048"/>
+          </a:xfrm>
+          <a:prstGeom prst="rect">
+            <a:avLst/>
+          </a:prstGeom>
+          <a:noFill/>
+          <a:ln/>
+        </p:spPr>
+        <p:txBody>
+          <a:bodyPr wrap="square" lIns="0" tIns="0" rIns="0" bIns="0" rtlCol="0" anchor="ctr"/>
+          <a:lstStyle/>
+          <a:p>
+            <a:pPr indent="0" marL="0">
+              <a:buNone/>
+            </a:pPr>
+            <a:r>
+              <a:rPr lang="en-US" sz="950" dirty="0">
+                <a:solidFill>
+                  <a:srgbClr val="6E6E73"/>
+                </a:solidFill>
+                <a:latin typeface="Helvetica Neue" pitchFamily="34" charset="0"/>
+                <a:ea typeface="Helvetica Neue" pitchFamily="34" charset="-122"/>
+                <a:cs typeface="Helvetica Neue" pitchFamily="34" charset="-120"/>
+              </a:rPr>
+              <a:t>Cluster map; curves by group</a:t>
+            </a:r>
+            <a:endParaRPr lang="en-US" sz="950" dirty="0"/>
+          </a:p>
+        </p:txBody>
+      </p:sp>
+      <p:sp>
+        <p:nvSpPr>
+          <p:cNvPr id="35" name="Shape 33"/>
+          <p:cNvSpPr/>
+          <p:nvPr/>
+        </p:nvSpPr>
+        <p:spPr>
+          <a:xfrm>
+            <a:off x="4069080" y="3730752"/>
+            <a:ext cx="4343400" cy="0"/>
+          </a:xfrm>
+          <a:prstGeom prst="line">
+            <a:avLst/>
+          </a:prstGeom>
+          <a:noFill/>
+          <a:ln w="6350">
+            <a:solidFill>
+              <a:srgbClr val="D2D2D7"/>
+            </a:solidFill>
+            <a:prstDash val="solid"/>
+          </a:ln>
+        </p:spPr>
+      </p:sp>
+      <p:sp>
+        <p:nvSpPr>
+          <p:cNvPr id="36" name="Text 34"/>
+          <p:cNvSpPr txBox="1"/>
+          <p:nvPr/>
+        </p:nvSpPr>
+        <p:spPr>
+          <a:xfrm>
+            <a:off x="4069080" y="3776472"/>
+            <a:ext cx="914400" cy="384048"/>
+          </a:xfrm>
+          <a:prstGeom prst="rect">
+            <a:avLst/>
+          </a:prstGeom>
+          <a:noFill/>
+          <a:ln/>
+        </p:spPr>
+        <p:txBody>
+          <a:bodyPr wrap="square" lIns="0" tIns="0" rIns="0" bIns="0" rtlCol="0" anchor="ctr"/>
+          <a:lstStyle/>
+          <a:p>
+            <a:pPr indent="0" marL="0">
+              <a:buNone/>
+            </a:pPr>
+            <a:r>
+              <a:rPr lang="en-US" sz="1000" b="1" dirty="0">
+                <a:solidFill>
+                  <a:srgbClr val="1D1D1F"/>
+                </a:solidFill>
+                <a:latin typeface="Helvetica Neue" pitchFamily="34" charset="0"/>
+                <a:ea typeface="Helvetica Neue" pitchFamily="34" charset="-122"/>
+                <a:cs typeface="Helvetica Neue" pitchFamily="34" charset="-120"/>
+              </a:rPr>
+              <a:t>Musa Tabally</a:t>
+            </a:r>
+            <a:endParaRPr lang="en-US" sz="1000" dirty="0"/>
+          </a:p>
+        </p:txBody>
+      </p:sp>
+      <p:sp>
+        <p:nvSpPr>
+          <p:cNvPr id="37" name="Text 35"/>
+          <p:cNvSpPr txBox="1"/>
+          <p:nvPr/>
+        </p:nvSpPr>
+        <p:spPr>
+          <a:xfrm>
+            <a:off x="5029200" y="3776472"/>
+            <a:ext cx="1554480" cy="384048"/>
+          </a:xfrm>
+          <a:prstGeom prst="rect">
+            <a:avLst/>
+          </a:prstGeom>
+          <a:noFill/>
+          <a:ln/>
+        </p:spPr>
+        <p:txBody>
+          <a:bodyPr wrap="square" lIns="0" tIns="0" rIns="0" bIns="0" rtlCol="0" anchor="ctr"/>
+          <a:lstStyle/>
+          <a:p>
+            <a:pPr indent="0" marL="0">
+              <a:buNone/>
+            </a:pPr>
+            <a:r>
+              <a:rPr lang="en-US" sz="1000" dirty="0">
+                <a:solidFill>
+                  <a:srgbClr val="1D1D1F"/>
+                </a:solidFill>
+                <a:latin typeface="Helvetica Neue" pitchFamily="34" charset="0"/>
+                <a:ea typeface="Helvetica Neue" pitchFamily="34" charset="-122"/>
+                <a:cs typeface="Helvetica Neue" pitchFamily="34" charset="-120"/>
+              </a:rPr>
+              <a:t>Statistical test: expected vs. actual</a:t>
+            </a:r>
+            <a:endParaRPr lang="en-US" sz="1000" dirty="0"/>
+          </a:p>
+        </p:txBody>
+      </p:sp>
+      <p:sp>
+        <p:nvSpPr>
+          <p:cNvPr id="38" name="Text 36"/>
+          <p:cNvSpPr txBox="1"/>
+          <p:nvPr/>
+        </p:nvSpPr>
+        <p:spPr>
+          <a:xfrm>
+            <a:off x="6675120" y="3776472"/>
+            <a:ext cx="1783080" cy="384048"/>
+          </a:xfrm>
+          <a:prstGeom prst="rect">
+            <a:avLst/>
+          </a:prstGeom>
+          <a:noFill/>
+          <a:ln/>
+        </p:spPr>
+        <p:txBody>
+          <a:bodyPr wrap="square" lIns="0" tIns="0" rIns="0" bIns="0" rtlCol="0" anchor="ctr"/>
+          <a:lstStyle/>
+          <a:p>
+            <a:pPr indent="0" marL="0">
+              <a:buNone/>
+            </a:pPr>
+            <a:r>
+              <a:rPr lang="en-US" sz="950" dirty="0">
+                <a:solidFill>
+                  <a:srgbClr val="6E6E73"/>
+                </a:solidFill>
+                <a:latin typeface="Helvetica Neue" pitchFamily="34" charset="0"/>
+                <a:ea typeface="Helvetica Neue" pitchFamily="34" charset="-122"/>
+                <a:cs typeface="Helvetica Neue" pitchFamily="34" charset="-120"/>
+              </a:rPr>
+              <a:t>Gap over time; heatmap by month</a:t>
+            </a:r>
+            <a:endParaRPr lang="en-US" sz="950" dirty="0"/>
+          </a:p>
+        </p:txBody>
+      </p:sp>
+      <p:sp>
+        <p:nvSpPr>
+          <p:cNvPr id="39" name="Text 37"/>
+          <p:cNvSpPr txBox="1"/>
+          <p:nvPr/>
+        </p:nvSpPr>
+        <p:spPr>
+          <a:xfrm>
+            <a:off x="4069080" y="4370832"/>
             <a:ext cx="4297680" cy="228600"/>
           </a:xfrm>
           <a:prstGeom prst="rect">

</xml_diff>